<commit_message>
feat: implement delete validation, rejection reasons, client carousel, and sticky headers
</commit_message>
<xml_diff>
--- a/Miniaturas_Logos.pptx
+++ b/Miniaturas_Logos.pptx
@@ -7,6 +7,8 @@
   <p:sldIdLst>
     <p:sldId id="256" r:id="rId2"/>
     <p:sldId id="257" r:id="rId3"/>
+    <p:sldId id="258" r:id="rId4"/>
+    <p:sldId id="259" r:id="rId5"/>
   </p:sldIdLst>
   <p:sldSz cx="9144000" cy="6858000" type="screen4x3"/>
   <p:notesSz cx="6858000" cy="9144000"/>
@@ -289,7 +291,7 @@
           <a:p>
             <a:fld id="{99F5342C-D80E-4531-96C4-311B0EB5391E}" type="datetimeFigureOut">
               <a:rPr lang="es-VE" smtClean="0"/>
-              <a:t>1/8/2026</a:t>
+              <a:t>2/8/2026</a:t>
             </a:fld>
             <a:endParaRPr lang="es-VE"/>
           </a:p>
@@ -459,7 +461,7 @@
           <a:p>
             <a:fld id="{99F5342C-D80E-4531-96C4-311B0EB5391E}" type="datetimeFigureOut">
               <a:rPr lang="es-VE" smtClean="0"/>
-              <a:t>1/8/2026</a:t>
+              <a:t>2/8/2026</a:t>
             </a:fld>
             <a:endParaRPr lang="es-VE"/>
           </a:p>
@@ -639,7 +641,7 @@
           <a:p>
             <a:fld id="{99F5342C-D80E-4531-96C4-311B0EB5391E}" type="datetimeFigureOut">
               <a:rPr lang="es-VE" smtClean="0"/>
-              <a:t>1/8/2026</a:t>
+              <a:t>2/8/2026</a:t>
             </a:fld>
             <a:endParaRPr lang="es-VE"/>
           </a:p>
@@ -809,7 +811,7 @@
           <a:p>
             <a:fld id="{99F5342C-D80E-4531-96C4-311B0EB5391E}" type="datetimeFigureOut">
               <a:rPr lang="es-VE" smtClean="0"/>
-              <a:t>1/8/2026</a:t>
+              <a:t>2/8/2026</a:t>
             </a:fld>
             <a:endParaRPr lang="es-VE"/>
           </a:p>
@@ -1055,7 +1057,7 @@
           <a:p>
             <a:fld id="{99F5342C-D80E-4531-96C4-311B0EB5391E}" type="datetimeFigureOut">
               <a:rPr lang="es-VE" smtClean="0"/>
-              <a:t>1/8/2026</a:t>
+              <a:t>2/8/2026</a:t>
             </a:fld>
             <a:endParaRPr lang="es-VE"/>
           </a:p>
@@ -1343,7 +1345,7 @@
           <a:p>
             <a:fld id="{99F5342C-D80E-4531-96C4-311B0EB5391E}" type="datetimeFigureOut">
               <a:rPr lang="es-VE" smtClean="0"/>
-              <a:t>1/8/2026</a:t>
+              <a:t>2/8/2026</a:t>
             </a:fld>
             <a:endParaRPr lang="es-VE"/>
           </a:p>
@@ -1765,7 +1767,7 @@
           <a:p>
             <a:fld id="{99F5342C-D80E-4531-96C4-311B0EB5391E}" type="datetimeFigureOut">
               <a:rPr lang="es-VE" smtClean="0"/>
-              <a:t>1/8/2026</a:t>
+              <a:t>2/8/2026</a:t>
             </a:fld>
             <a:endParaRPr lang="es-VE"/>
           </a:p>
@@ -1883,7 +1885,7 @@
           <a:p>
             <a:fld id="{99F5342C-D80E-4531-96C4-311B0EB5391E}" type="datetimeFigureOut">
               <a:rPr lang="es-VE" smtClean="0"/>
-              <a:t>1/8/2026</a:t>
+              <a:t>2/8/2026</a:t>
             </a:fld>
             <a:endParaRPr lang="es-VE"/>
           </a:p>
@@ -1978,7 +1980,7 @@
           <a:p>
             <a:fld id="{99F5342C-D80E-4531-96C4-311B0EB5391E}" type="datetimeFigureOut">
               <a:rPr lang="es-VE" smtClean="0"/>
-              <a:t>1/8/2026</a:t>
+              <a:t>2/8/2026</a:t>
             </a:fld>
             <a:endParaRPr lang="es-VE"/>
           </a:p>
@@ -2255,7 +2257,7 @@
           <a:p>
             <a:fld id="{99F5342C-D80E-4531-96C4-311B0EB5391E}" type="datetimeFigureOut">
               <a:rPr lang="es-VE" smtClean="0"/>
-              <a:t>1/8/2026</a:t>
+              <a:t>2/8/2026</a:t>
             </a:fld>
             <a:endParaRPr lang="es-VE"/>
           </a:p>
@@ -2508,7 +2510,7 @@
           <a:p>
             <a:fld id="{99F5342C-D80E-4531-96C4-311B0EB5391E}" type="datetimeFigureOut">
               <a:rPr lang="es-VE" smtClean="0"/>
-              <a:t>1/8/2026</a:t>
+              <a:t>2/8/2026</a:t>
             </a:fld>
             <a:endParaRPr lang="es-VE"/>
           </a:p>
@@ -2721,7 +2723,7 @@
           <a:p>
             <a:fld id="{99F5342C-D80E-4531-96C4-311B0EB5391E}" type="datetimeFigureOut">
               <a:rPr lang="es-VE" smtClean="0"/>
-              <a:t>1/8/2026</a:t>
+              <a:t>2/8/2026</a:t>
             </a:fld>
             <a:endParaRPr lang="es-VE"/>
           </a:p>
@@ -3507,6 +3509,368 @@
 </p:sld>
 </file>
 
+<file path=ppt/slides/slide3.xml><?xml version="1.0" encoding="utf-8"?>
+<p:sld xmlns:a="http://schemas.openxmlformats.org/drawingml/2006/main" xmlns:r="http://schemas.openxmlformats.org/officeDocument/2006/relationships" xmlns:p="http://schemas.openxmlformats.org/presentationml/2006/main">
+  <p:cSld>
+    <p:spTree>
+      <p:nvGrpSpPr>
+        <p:cNvPr id="1" name=""/>
+        <p:cNvGrpSpPr/>
+        <p:nvPr/>
+      </p:nvGrpSpPr>
+      <p:grpSpPr>
+        <a:xfrm>
+          <a:off x="0" y="0"/>
+          <a:ext cx="0" cy="0"/>
+          <a:chOff x="0" y="0"/>
+          <a:chExt cx="0" cy="0"/>
+        </a:xfrm>
+      </p:grpSpPr>
+      <p:sp>
+        <p:nvSpPr>
+          <p:cNvPr id="4" name="3 Rectángulo"/>
+          <p:cNvSpPr/>
+          <p:nvPr/>
+        </p:nvSpPr>
+        <p:spPr>
+          <a:xfrm>
+            <a:off x="393157" y="764704"/>
+            <a:ext cx="4466875" cy="3108543"/>
+          </a:xfrm>
+          <a:prstGeom prst="rect">
+            <a:avLst/>
+          </a:prstGeom>
+        </p:spPr>
+        <p:txBody>
+          <a:bodyPr wrap="square">
+            <a:spAutoFit/>
+          </a:bodyPr>
+          <a:lstStyle/>
+          <a:p>
+            <a:r>
+              <a:rPr lang="es-ES" sz="1400" b="1" dirty="0" smtClean="0"/>
+              <a:t>TTP </a:t>
+            </a:r>
+            <a:r>
+              <a:rPr lang="es-ES" sz="1400" b="1" dirty="0"/>
+              <a:t>(Tiempo Total </a:t>
+            </a:r>
+            <a:r>
+              <a:rPr lang="es-ES" sz="1400" b="1"/>
+              <a:t>en </a:t>
+            </a:r>
+            <a:r>
+              <a:rPr lang="es-ES" sz="1400" b="1" smtClean="0"/>
+              <a:t>Producción):</a:t>
+            </a:r>
+            <a:endParaRPr lang="es-ES" sz="1400" b="1" dirty="0"/>
+          </a:p>
+          <a:p>
+            <a:r>
+              <a:rPr lang="es-ES" sz="1400" dirty="0"/>
+              <a:t>Ideal si tu sistema mide el reloj corrido desde que la orden de producción entra a esa fase hasta que sale</a:t>
+            </a:r>
+            <a:r>
+              <a:rPr lang="es-ES" sz="1400" dirty="0" smtClean="0"/>
+              <a:t>.</a:t>
+            </a:r>
+          </a:p>
+          <a:p>
+            <a:endParaRPr lang="es-ES" sz="1400" dirty="0"/>
+          </a:p>
+          <a:p>
+            <a:r>
+              <a:rPr lang="es-ES" sz="1400" b="1" dirty="0" smtClean="0"/>
+              <a:t>Tiempo </a:t>
+            </a:r>
+            <a:r>
+              <a:rPr lang="es-ES" sz="1400" b="1" dirty="0"/>
+              <a:t>de Ciclo por Etapa (TCE):</a:t>
+            </a:r>
+          </a:p>
+          <a:p>
+            <a:r>
+              <a:rPr lang="es-ES" sz="1400" dirty="0"/>
+              <a:t>Es el tiempo total transcurrido en la etapa. Sirve para calcular el rendimiento global de la línea</a:t>
+            </a:r>
+            <a:r>
+              <a:rPr lang="es-ES" sz="1400" dirty="0" smtClean="0"/>
+              <a:t>.</a:t>
+            </a:r>
+          </a:p>
+          <a:p>
+            <a:endParaRPr lang="es-ES" sz="1400" dirty="0"/>
+          </a:p>
+          <a:p>
+            <a:r>
+              <a:rPr lang="es-ES" sz="1400" b="1" dirty="0" smtClean="0"/>
+              <a:t>TCE </a:t>
+            </a:r>
+            <a:r>
+              <a:rPr lang="es-ES" sz="1400" b="1" dirty="0"/>
+              <a:t>= Hora de Salida de la Etapa - Hora de Entrada a la </a:t>
+            </a:r>
+            <a:r>
+              <a:rPr lang="es-ES" sz="1400" b="1" dirty="0" smtClean="0"/>
+              <a:t>Etapa</a:t>
+            </a:r>
+          </a:p>
+          <a:p>
+            <a:endParaRPr lang="es-ES" sz="1400" b="1" dirty="0"/>
+          </a:p>
+          <a:p>
+            <a:r>
+              <a:rPr lang="es-VE" sz="1400" b="1" dirty="0" smtClean="0"/>
+              <a:t>DRE </a:t>
+            </a:r>
+            <a:r>
+              <a:rPr lang="es-VE" sz="1400" b="1" dirty="0"/>
+              <a:t>(Días Restantes para Entrega):</a:t>
+            </a:r>
+          </a:p>
+          <a:p>
+            <a:r>
+              <a:rPr lang="es-ES" sz="1400" dirty="0"/>
+              <a:t>Es el más directo y fácil de entender para cualquier operador o supervisor en planta.</a:t>
+            </a:r>
+          </a:p>
+        </p:txBody>
+      </p:sp>
+      <p:pic>
+        <p:nvPicPr>
+          <p:cNvPr id="1026" name="Picture 2"/>
+          <p:cNvPicPr>
+            <a:picLocks noChangeAspect="1" noChangeArrowheads="1"/>
+          </p:cNvPicPr>
+          <p:nvPr/>
+        </p:nvPicPr>
+        <p:blipFill>
+          <a:blip r:embed="rId2">
+            <a:extLst>
+              <a:ext uri="{28A0092B-C50C-407E-A947-70E740481C1C}">
+                <a14:useLocalDpi xmlns:a14="http://schemas.microsoft.com/office/drawing/2010/main" val="0"/>
+              </a:ext>
+            </a:extLst>
+          </a:blip>
+          <a:srcRect/>
+          <a:stretch>
+            <a:fillRect/>
+          </a:stretch>
+        </p:blipFill>
+        <p:spPr bwMode="auto">
+          <a:xfrm>
+            <a:off x="4957518" y="1016552"/>
+            <a:ext cx="3934962" cy="2117408"/>
+          </a:xfrm>
+          <a:prstGeom prst="rect">
+            <a:avLst/>
+          </a:prstGeom>
+          <a:noFill/>
+          <a:ln>
+            <a:noFill/>
+          </a:ln>
+          <a:effectLst/>
+          <a:extLst>
+            <a:ext uri="{909E8E84-426E-40DD-AFC4-6F175D3DCCD1}">
+              <a14:hiddenFill xmlns:a14="http://schemas.microsoft.com/office/drawing/2010/main">
+                <a:solidFill>
+                  <a:schemeClr val="accent1"/>
+                </a:solidFill>
+              </a14:hiddenFill>
+            </a:ext>
+            <a:ext uri="{91240B29-F687-4F45-9708-019B960494DF}">
+              <a14:hiddenLine xmlns:a14="http://schemas.microsoft.com/office/drawing/2010/main" w="9525">
+                <a:solidFill>
+                  <a:schemeClr val="tx1"/>
+                </a:solidFill>
+                <a:miter lim="800000"/>
+                <a:headEnd/>
+                <a:tailEnd/>
+              </a14:hiddenLine>
+            </a:ext>
+            <a:ext uri="{AF507438-7753-43E0-B8FC-AC1667EBCBE1}">
+              <a14:hiddenEffects xmlns:a14="http://schemas.microsoft.com/office/drawing/2010/main">
+                <a:effectLst>
+                  <a:outerShdw dist="35921" dir="2700000" algn="ctr" rotWithShape="0">
+                    <a:schemeClr val="bg2"/>
+                  </a:outerShdw>
+                </a:effectLst>
+              </a14:hiddenEffects>
+            </a:ext>
+          </a:extLst>
+        </p:spPr>
+      </p:pic>
+      <p:pic>
+        <p:nvPicPr>
+          <p:cNvPr id="7" name="Picture 1"/>
+          <p:cNvPicPr>
+            <a:picLocks noChangeAspect="1" noChangeArrowheads="1"/>
+          </p:cNvPicPr>
+          <p:nvPr/>
+        </p:nvPicPr>
+        <p:blipFill>
+          <a:blip r:embed="rId3">
+            <a:extLst>
+              <a:ext uri="{28A0092B-C50C-407E-A947-70E740481C1C}">
+                <a14:useLocalDpi xmlns:a14="http://schemas.microsoft.com/office/drawing/2010/main" val="0"/>
+              </a:ext>
+            </a:extLst>
+          </a:blip>
+          <a:srcRect/>
+          <a:stretch>
+            <a:fillRect/>
+          </a:stretch>
+        </p:blipFill>
+        <p:spPr bwMode="auto">
+          <a:xfrm>
+            <a:off x="1187624" y="4293096"/>
+            <a:ext cx="5951537" cy="1920875"/>
+          </a:xfrm>
+          <a:prstGeom prst="rect">
+            <a:avLst/>
+          </a:prstGeom>
+          <a:noFill/>
+          <a:ln>
+            <a:noFill/>
+          </a:ln>
+          <a:effectLst/>
+          <a:extLst>
+            <a:ext uri="{909E8E84-426E-40DD-AFC4-6F175D3DCCD1}">
+              <a14:hiddenFill xmlns:a14="http://schemas.microsoft.com/office/drawing/2010/main">
+                <a:solidFill>
+                  <a:schemeClr val="accent1"/>
+                </a:solidFill>
+              </a14:hiddenFill>
+            </a:ext>
+            <a:ext uri="{91240B29-F687-4F45-9708-019B960494DF}">
+              <a14:hiddenLine xmlns:a14="http://schemas.microsoft.com/office/drawing/2010/main" w="9525">
+                <a:solidFill>
+                  <a:schemeClr val="tx1"/>
+                </a:solidFill>
+                <a:miter lim="800000"/>
+                <a:headEnd/>
+                <a:tailEnd/>
+              </a14:hiddenLine>
+            </a:ext>
+            <a:ext uri="{AF507438-7753-43E0-B8FC-AC1667EBCBE1}">
+              <a14:hiddenEffects xmlns:a14="http://schemas.microsoft.com/office/drawing/2010/main">
+                <a:effectLst>
+                  <a:outerShdw dist="35921" dir="2700000" algn="ctr" rotWithShape="0">
+                    <a:schemeClr val="bg2"/>
+                  </a:outerShdw>
+                </a:effectLst>
+              </a14:hiddenEffects>
+            </a:ext>
+          </a:extLst>
+        </p:spPr>
+      </p:pic>
+    </p:spTree>
+    <p:extLst>
+      <p:ext uri="{BB962C8B-B14F-4D97-AF65-F5344CB8AC3E}">
+        <p14:creationId xmlns:p14="http://schemas.microsoft.com/office/powerpoint/2010/main" val="2680898912"/>
+      </p:ext>
+    </p:extLst>
+  </p:cSld>
+  <p:clrMapOvr>
+    <a:masterClrMapping/>
+  </p:clrMapOvr>
+</p:sld>
+</file>
+
+<file path=ppt/slides/slide4.xml><?xml version="1.0" encoding="utf-8"?>
+<p:sld xmlns:a="http://schemas.openxmlformats.org/drawingml/2006/main" xmlns:r="http://schemas.openxmlformats.org/officeDocument/2006/relationships" xmlns:p="http://schemas.openxmlformats.org/presentationml/2006/main">
+  <p:cSld>
+    <p:spTree>
+      <p:nvGrpSpPr>
+        <p:cNvPr id="1" name=""/>
+        <p:cNvGrpSpPr/>
+        <p:nvPr/>
+      </p:nvGrpSpPr>
+      <p:grpSpPr>
+        <a:xfrm>
+          <a:off x="0" y="0"/>
+          <a:ext cx="0" cy="0"/>
+          <a:chOff x="0" y="0"/>
+          <a:chExt cx="0" cy="0"/>
+        </a:xfrm>
+      </p:grpSpPr>
+      <p:pic>
+        <p:nvPicPr>
+          <p:cNvPr id="2049" name="Picture 1"/>
+          <p:cNvPicPr>
+            <a:picLocks noChangeAspect="1" noChangeArrowheads="1"/>
+          </p:cNvPicPr>
+          <p:nvPr/>
+        </p:nvPicPr>
+        <p:blipFill>
+          <a:blip r:embed="rId2">
+            <a:extLst>
+              <a:ext uri="{28A0092B-C50C-407E-A947-70E740481C1C}">
+                <a14:useLocalDpi xmlns:a14="http://schemas.microsoft.com/office/drawing/2010/main" val="0"/>
+              </a:ext>
+            </a:extLst>
+          </a:blip>
+          <a:srcRect/>
+          <a:stretch>
+            <a:fillRect/>
+          </a:stretch>
+        </p:blipFill>
+        <p:spPr bwMode="auto">
+          <a:xfrm>
+            <a:off x="683568" y="692696"/>
+            <a:ext cx="5951537" cy="1920875"/>
+          </a:xfrm>
+          <a:prstGeom prst="rect">
+            <a:avLst/>
+          </a:prstGeom>
+          <a:noFill/>
+          <a:ln>
+            <a:noFill/>
+          </a:ln>
+          <a:effectLst/>
+          <a:extLst>
+            <a:ext uri="{909E8E84-426E-40DD-AFC4-6F175D3DCCD1}">
+              <a14:hiddenFill xmlns:a14="http://schemas.microsoft.com/office/drawing/2010/main">
+                <a:solidFill>
+                  <a:schemeClr val="accent1"/>
+                </a:solidFill>
+              </a14:hiddenFill>
+            </a:ext>
+            <a:ext uri="{91240B29-F687-4F45-9708-019B960494DF}">
+              <a14:hiddenLine xmlns:a14="http://schemas.microsoft.com/office/drawing/2010/main" w="9525">
+                <a:solidFill>
+                  <a:schemeClr val="tx1"/>
+                </a:solidFill>
+                <a:miter lim="800000"/>
+                <a:headEnd/>
+                <a:tailEnd/>
+              </a14:hiddenLine>
+            </a:ext>
+            <a:ext uri="{AF507438-7753-43E0-B8FC-AC1667EBCBE1}">
+              <a14:hiddenEffects xmlns:a14="http://schemas.microsoft.com/office/drawing/2010/main">
+                <a:effectLst>
+                  <a:outerShdw dist="35921" dir="2700000" algn="ctr" rotWithShape="0">
+                    <a:schemeClr val="bg2"/>
+                  </a:outerShdw>
+                </a:effectLst>
+              </a14:hiddenEffects>
+            </a:ext>
+          </a:extLst>
+        </p:spPr>
+      </p:pic>
+    </p:spTree>
+    <p:extLst>
+      <p:ext uri="{BB962C8B-B14F-4D97-AF65-F5344CB8AC3E}">
+        <p14:creationId xmlns:p14="http://schemas.microsoft.com/office/powerpoint/2010/main" val="2662189237"/>
+      </p:ext>
+    </p:extLst>
+  </p:cSld>
+  <p:clrMapOvr>
+    <a:masterClrMapping/>
+  </p:clrMapOvr>
+</p:sld>
+</file>
+
 <file path=ppt/theme/theme1.xml><?xml version="1.0" encoding="utf-8"?>
 <a:theme xmlns:a="http://schemas.openxmlformats.org/drawingml/2006/main" name="Tema de Office">
   <a:themeElements>

</xml_diff>